<commit_message>
refactor: rename project ProcPulse to ProcScope across code, build, tests and docs
</commit_message>
<xml_diff>
--- a/docs/ProcScope-Interview-Deck.pptx
+++ b/docs/ProcScope-Interview-Deck.pptx
@@ -602,7 +602,7 @@
                   <a:srgbClr val="64748B"/>
                 </a:solidFill>
               </a:rPr>
-              <a:t>github.com/rudraprakashnayak/procpulse</a:t>
+              <a:t>github.com/rudraprakashnayak/procscope</a:t>
             </a:r>
           </a:p>
         </p:txBody>
@@ -1329,7 +1329,7 @@
                 <a:latin typeface="Consolas"/>
                 <a:ea typeface="Consolas"/>
               </a:rPr>
-              <a:t>github.com/rudraprakashnayak/procpulse</a:t>
+              <a:t>github.com/rudraprakashnayak/procscope</a:t>
             </a:r>
           </a:p>
         </p:txBody>
@@ -5025,7 +5025,7 @@
                 <a:latin typeface="Consolas"/>
                 <a:ea typeface="Consolas"/>
               </a:rPr>
-              <a:t>./build/procpulse</a:t>
+              <a:t>./build/procscope</a:t>
             </a:r>
           </a:p>
         </p:txBody>
@@ -5742,7 +5742,7 @@
                   <a:srgbClr val="E2E8F0"/>
                 </a:solidFill>
               </a:rPr>
-              <a:t>run_integration.sh runs build/procpulse --root tests/fixtures --once and greps exact lines: load average 0.5 0.6 0.6, Processes (2), device nodes 2</a:t>
+              <a:t>run_integration.sh runs build/procscope --root tests/fixtures --once and greps exact lines: load average 0.5 0.6 0.6, Processes (2), device nodes 2</a:t>
             </a:r>
           </a:p>
         </p:txBody>

</xml_diff>

<commit_message>
docs: correct presenter name and GitHub URL in interview deck
</commit_message>
<xml_diff>
--- a/docs/ProcScope-Interview-Deck.pptx
+++ b/docs/ProcScope-Interview-Deck.pptx
@@ -346,7 +346,7 @@
                   <a:srgbClr val="E2E8F0"/>
                 </a:solidFill>
               </a:rPr>
-              <a:t>Presented by Rudra Prakash Nayak</a:t>
+              <a:t>Presented by Swoyam Sambhab Dasmohaptra</a:t>
             </a:r>
           </a:p>
         </p:txBody>
@@ -602,7 +602,7 @@
                   <a:srgbClr val="64748B"/>
                 </a:solidFill>
               </a:rPr>
-              <a:t>github.com/rudraprakashnayak/procscope</a:t>
+              <a:t>github.com/iamswoyam/procscope</a:t>
             </a:r>
           </a:p>
         </p:txBody>
@@ -1329,7 +1329,7 @@
                 <a:latin typeface="Consolas"/>
                 <a:ea typeface="Consolas"/>
               </a:rPr>
-              <a:t>github.com/rudraprakashnayak/procscope</a:t>
+              <a:t>github.com/iamswoyam/procscope</a:t>
             </a:r>
           </a:p>
         </p:txBody>

</xml_diff>